<commit_message>
fixed slide about errors
</commit_message>
<xml_diff>
--- a/Time_Series_Forecasting.pptx
+++ b/Time_Series_Forecasting.pptx
@@ -25496,7 +25496,7 @@
         </p:nvSpPr>
         <p:spPr>
           <a:xfrm>
-            <a:off x="123986" y="1106115"/>
+            <a:off x="123986" y="691055"/>
             <a:ext cx="6137329" cy="707886"/>
           </a:xfrm>
           <a:prstGeom prst="rect">
@@ -25595,23 +25595,21 @@
           </p:cNvPicPr>
           <p:nvPr/>
         </p:nvPicPr>
-        <p:blipFill>
-          <a:blip r:embed="rId4">
+        <p:blipFill rotWithShape="1">
+          <a:blip r:embed="rId4" cstate="email">
             <a:extLst>
               <a:ext uri="{28A0092B-C50C-407E-A947-70E740481C1C}">
                 <a14:useLocalDpi xmlns:a14="http://schemas.microsoft.com/office/drawing/2010/main"/>
               </a:ext>
             </a:extLst>
           </a:blip>
-          <a:srcRect/>
-          <a:stretch>
-            <a:fillRect/>
-          </a:stretch>
+          <a:srcRect l="7676" r="5888" b="57988"/>
+          <a:stretch/>
         </p:blipFill>
         <p:spPr bwMode="auto">
           <a:xfrm>
-            <a:off x="3754519" y="2197083"/>
-            <a:ext cx="3276600" cy="3009900"/>
+            <a:off x="8955551" y="5473155"/>
+            <a:ext cx="2156346" cy="962776"/>
           </a:xfrm>
           <a:prstGeom prst="rect">
             <a:avLst/>
@@ -25673,59 +25671,6 @@
           </a:extLst>
         </p:spPr>
       </p:pic>
-      <p:sp>
-        <p:nvSpPr>
-          <p:cNvPr id="3" name="TextBox 2">
-            <a:extLst>
-              <a:ext uri="{FF2B5EF4-FFF2-40B4-BE49-F238E27FC236}">
-                <a16:creationId xmlns:a16="http://schemas.microsoft.com/office/drawing/2014/main" id="{4F3BE338-6E7B-A347-9277-0B5D1345872A}"/>
-              </a:ext>
-            </a:extLst>
-          </p:cNvPr>
-          <p:cNvSpPr txBox="1"/>
-          <p:nvPr/>
-        </p:nvSpPr>
-        <p:spPr>
-          <a:xfrm>
-            <a:off x="123986" y="2732537"/>
-            <a:ext cx="4016214" cy="1938992"/>
-          </a:xfrm>
-          <a:prstGeom prst="rect">
-            <a:avLst/>
-          </a:prstGeom>
-          <a:noFill/>
-        </p:spPr>
-        <p:txBody>
-          <a:bodyPr wrap="square" rtlCol="0">
-            <a:spAutoFit/>
-          </a:bodyPr>
-          <a:lstStyle/>
-          <a:p>
-            <a:r>
-              <a:rPr lang="en-US" sz="2000" dirty="0"/>
-              <a:t>Mean Squared Error</a:t>
-            </a:r>
-          </a:p>
-          <a:p>
-            <a:endParaRPr lang="en-US" sz="2000" dirty="0"/>
-          </a:p>
-          <a:p>
-            <a:endParaRPr lang="en-US" sz="2000" dirty="0"/>
-          </a:p>
-          <a:p>
-            <a:endParaRPr lang="en-US" sz="2000" dirty="0"/>
-          </a:p>
-          <a:p>
-            <a:endParaRPr lang="en-US" sz="2000" dirty="0"/>
-          </a:p>
-          <a:p>
-            <a:r>
-              <a:rPr lang="en-US" sz="2000" dirty="0"/>
-              <a:t>Mean Absolute Percentage Error</a:t>
-            </a:r>
-          </a:p>
-        </p:txBody>
-      </p:sp>
       <p:pic>
         <p:nvPicPr>
           <p:cNvPr id="3082" name="Picture 10" descr="Statistical Forecast Errors">
@@ -25755,8 +25700,8 @@
         </p:blipFill>
         <p:spPr bwMode="auto">
           <a:xfrm>
-            <a:off x="5092915" y="5473155"/>
-            <a:ext cx="4962497" cy="962776"/>
+            <a:off x="8659287" y="3163515"/>
+            <a:ext cx="3069355" cy="595487"/>
           </a:xfrm>
           <a:prstGeom prst="rect">
             <a:avLst/>
@@ -25773,12 +25718,59 @@
           </a:extLst>
         </p:spPr>
       </p:pic>
+      <p:pic>
+        <p:nvPicPr>
+          <p:cNvPr id="1026" name="Picture 2" descr="Image result for wape weighted absolute percentage error">
+            <a:extLst>
+              <a:ext uri="{FF2B5EF4-FFF2-40B4-BE49-F238E27FC236}">
+                <a16:creationId xmlns:a16="http://schemas.microsoft.com/office/drawing/2014/main" id="{91235511-1277-0E43-B807-16222CC06914}"/>
+              </a:ext>
+            </a:extLst>
+          </p:cNvPr>
+          <p:cNvPicPr>
+            <a:picLocks noChangeAspect="1" noChangeArrowheads="1"/>
+          </p:cNvPicPr>
+          <p:nvPr/>
+        </p:nvPicPr>
+        <p:blipFill>
+          <a:blip r:embed="rId7" cstate="email">
+            <a:extLst>
+              <a:ext uri="{28A0092B-C50C-407E-A947-70E740481C1C}">
+                <a14:useLocalDpi xmlns:a14="http://schemas.microsoft.com/office/drawing/2010/main"/>
+              </a:ext>
+            </a:extLst>
+          </a:blip>
+          <a:srcRect/>
+          <a:stretch>
+            <a:fillRect/>
+          </a:stretch>
+        </p:blipFill>
+        <p:spPr bwMode="auto">
+          <a:xfrm>
+            <a:off x="8955551" y="4921809"/>
+            <a:ext cx="2283135" cy="561833"/>
+          </a:xfrm>
+          <a:prstGeom prst="rect">
+            <a:avLst/>
+          </a:prstGeom>
+          <a:noFill/>
+          <a:extLst>
+            <a:ext uri="{909E8E84-426E-40DD-AFC4-6F175D3DCCD1}">
+              <a14:hiddenFill xmlns:a14="http://schemas.microsoft.com/office/drawing/2010/main">
+                <a:solidFill>
+                  <a:srgbClr val="FFFFFF"/>
+                </a:solidFill>
+              </a14:hiddenFill>
+            </a:ext>
+          </a:extLst>
+        </p:spPr>
+      </p:pic>
       <p:sp>
         <p:nvSpPr>
-          <p:cNvPr id="10" name="TextBox 9">
+          <p:cNvPr id="4" name="TextBox 3">
             <a:extLst>
               <a:ext uri="{FF2B5EF4-FFF2-40B4-BE49-F238E27FC236}">
-                <a16:creationId xmlns:a16="http://schemas.microsoft.com/office/drawing/2014/main" id="{FE783D0A-462A-884F-9F86-01A8F99E2BAB}"/>
+                <a16:creationId xmlns:a16="http://schemas.microsoft.com/office/drawing/2014/main" id="{EAC6536B-7DC6-7146-904E-52A74607F841}"/>
               </a:ext>
             </a:extLst>
           </p:cNvPr>
@@ -25787,8 +25779,8 @@
         </p:nvSpPr>
         <p:spPr>
           <a:xfrm>
-            <a:off x="3982097" y="5666265"/>
-            <a:ext cx="1273014" cy="400110"/>
+            <a:off x="272955" y="1450189"/>
+            <a:ext cx="6646460" cy="4616648"/>
           </a:xfrm>
           <a:prstGeom prst="rect">
             <a:avLst/>
@@ -25802,12 +25794,219 @@
           <a:lstStyle/>
           <a:p>
             <a:r>
-              <a:rPr lang="en-US" sz="2000" dirty="0"/>
-              <a:t>MAPE = </a:t>
+              <a:rPr lang="en-US" dirty="0"/>
+              <a:t>There are multiple methods:</a:t>
+            </a:r>
+          </a:p>
+          <a:p>
+            <a:r>
+              <a:rPr lang="en-US" dirty="0">
+                <a:solidFill>
+                  <a:srgbClr val="0070C0"/>
+                </a:solidFill>
+              </a:rPr>
+              <a:t>MAPE = Mean Absolute Percentage Error</a:t>
+            </a:r>
+          </a:p>
+          <a:p>
+            <a:r>
+              <a:rPr lang="en-US" dirty="0">
+                <a:solidFill>
+                  <a:srgbClr val="0070C0"/>
+                </a:solidFill>
+              </a:rPr>
+              <a:t>WAPE = Weighted Absolute Percentage Error</a:t>
+            </a:r>
+          </a:p>
+          <a:p>
+            <a:r>
+              <a:rPr lang="en-US" dirty="0">
+                <a:solidFill>
+                  <a:srgbClr val="0070C0"/>
+                </a:solidFill>
+              </a:rPr>
+              <a:t>MSE = Mean Squared Error</a:t>
+            </a:r>
+          </a:p>
+          <a:p>
+            <a:r>
+              <a:rPr lang="en-US" dirty="0">
+                <a:solidFill>
+                  <a:srgbClr val="0070C0"/>
+                </a:solidFill>
+              </a:rPr>
+              <a:t>RMSE = Root Mean Square Error</a:t>
+            </a:r>
+          </a:p>
+          <a:p>
+            <a:r>
+              <a:rPr lang="en-US" dirty="0">
+                <a:solidFill>
+                  <a:srgbClr val="0070C0"/>
+                </a:solidFill>
+              </a:rPr>
+              <a:t>NMAPE – Normalized MAPE</a:t>
+            </a:r>
+          </a:p>
+          <a:p>
+            <a:r>
+              <a:rPr lang="en-US" dirty="0">
+                <a:solidFill>
+                  <a:srgbClr val="0070C0"/>
+                </a:solidFill>
+              </a:rPr>
+              <a:t>NRMSE – Normalized RMSE</a:t>
+            </a:r>
+          </a:p>
+          <a:p>
+            <a:r>
+              <a:rPr lang="en-US" dirty="0">
+                <a:solidFill>
+                  <a:srgbClr val="0070C0"/>
+                </a:solidFill>
+              </a:rPr>
+              <a:t>R2 score</a:t>
+            </a:r>
+          </a:p>
+          <a:p>
+            <a:r>
+              <a:rPr lang="en-US" dirty="0">
+                <a:solidFill>
+                  <a:srgbClr val="0070C0"/>
+                </a:solidFill>
+              </a:rPr>
+              <a:t>Spearman Correlation</a:t>
+            </a:r>
+          </a:p>
+          <a:p>
+            <a:r>
+              <a:rPr lang="en-US" dirty="0">
+                <a:solidFill>
+                  <a:srgbClr val="0070C0"/>
+                </a:solidFill>
+              </a:rPr>
+              <a:t>etc.</a:t>
+            </a:r>
+          </a:p>
+          <a:p>
+            <a:endParaRPr lang="en-US" dirty="0"/>
+          </a:p>
+          <a:p>
+            <a:r>
+              <a:rPr lang="en-US" dirty="0"/>
+              <a:t>Normalization can be done in different ways:</a:t>
+            </a:r>
+          </a:p>
+          <a:p>
+            <a:pPr marL="285750" indent="-285750">
+              <a:buFont typeface="Arial" panose="020B0604020202020204" pitchFamily="34" charset="0"/>
+              <a:buChar char="•"/>
+            </a:pPr>
+            <a:r>
+              <a:rPr lang="en-US" dirty="0"/>
+              <a:t>by difference between maximum and minimum</a:t>
+            </a:r>
+          </a:p>
+          <a:p>
+            <a:pPr marL="285750" indent="-285750">
+              <a:buFont typeface="Arial" panose="020B0604020202020204" pitchFamily="34" charset="0"/>
+              <a:buChar char="•"/>
+            </a:pPr>
+            <a:r>
+              <a:rPr lang="en-US" dirty="0"/>
+              <a:t>by standard deviation of the "actual" curve</a:t>
+            </a:r>
+          </a:p>
+          <a:p>
+            <a:pPr marL="285750" indent="-285750">
+              <a:buFont typeface="Arial" panose="020B0604020202020204" pitchFamily="34" charset="0"/>
+              <a:buChar char="•"/>
+            </a:pPr>
+            <a:r>
+              <a:rPr lang="en-US" dirty="0"/>
+              <a:t>by mean value - not good, error will depend on vertical shift</a:t>
+            </a:r>
+          </a:p>
+          <a:p>
+            <a:pPr marL="285750" indent="-285750">
+              <a:buFont typeface="Arial" panose="020B0604020202020204" pitchFamily="34" charset="0"/>
+              <a:buChar char="•"/>
+            </a:pPr>
+            <a:r>
+              <a:rPr lang="en-US" dirty="0"/>
+              <a:t>by interquartile range (i.e. the difference between 25th and 75th percentile) – not good, depends </a:t>
+            </a:r>
+            <a:r>
+              <a:rPr lang="en-US" dirty="0" err="1"/>
+              <a:t>ondistribution</a:t>
+            </a:r>
+            <a:r>
+              <a:rPr lang="en-US" dirty="0"/>
+              <a:t> of points between quartiles</a:t>
+            </a:r>
+          </a:p>
+          <a:p>
+            <a:endParaRPr lang="en-US" dirty="0"/>
+          </a:p>
+          <a:p>
+            <a:r>
+              <a:rPr lang="en-US" dirty="0"/>
+              <a:t>Real life error function should be custom fit to your data and business case.</a:t>
+            </a:r>
+          </a:p>
+          <a:p>
+            <a:r>
+              <a:rPr lang="en-US" dirty="0"/>
+              <a:t>And normalization should not depend only on min/max or mean – but probably on combination of different characteristics – and treat "zero" cases carefully.</a:t>
             </a:r>
           </a:p>
         </p:txBody>
       </p:sp>
+      <p:pic>
+        <p:nvPicPr>
+          <p:cNvPr id="11" name="Picture 6" descr="Mape Equation Photos Download JPG, PNG, GIF, RAW, TIFF, PSD, PDF and Watch  Online">
+            <a:extLst>
+              <a:ext uri="{FF2B5EF4-FFF2-40B4-BE49-F238E27FC236}">
+                <a16:creationId xmlns:a16="http://schemas.microsoft.com/office/drawing/2014/main" id="{E79DDDC4-7419-934A-BFF6-56CA308824D5}"/>
+              </a:ext>
+            </a:extLst>
+          </p:cNvPr>
+          <p:cNvPicPr>
+            <a:picLocks noChangeAspect="1" noChangeArrowheads="1"/>
+          </p:cNvPicPr>
+          <p:nvPr/>
+        </p:nvPicPr>
+        <p:blipFill rotWithShape="1">
+          <a:blip r:embed="rId4" cstate="email">
+            <a:extLst>
+              <a:ext uri="{28A0092B-C50C-407E-A947-70E740481C1C}">
+                <a14:useLocalDpi xmlns:a14="http://schemas.microsoft.com/office/drawing/2010/main"/>
+              </a:ext>
+            </a:extLst>
+          </a:blip>
+          <a:srcRect l="4303" t="57988" b="8734"/>
+          <a:stretch/>
+        </p:blipFill>
+        <p:spPr bwMode="auto">
+          <a:xfrm>
+            <a:off x="8851303" y="4008311"/>
+            <a:ext cx="2387383" cy="762612"/>
+          </a:xfrm>
+          <a:prstGeom prst="rect">
+            <a:avLst/>
+          </a:prstGeom>
+          <a:noFill/>
+          <a:extLst>
+            <a:ext uri="{909E8E84-426E-40DD-AFC4-6F175D3DCCD1}">
+              <a14:hiddenFill xmlns:a14="http://schemas.microsoft.com/office/drawing/2010/main">
+                <a:solidFill>
+                  <a:srgbClr val="FFFFFF"/>
+                </a:solidFill>
+              </a14:hiddenFill>
+            </a:ext>
+          </a:extLst>
+        </p:spPr>
+      </p:pic>
     </p:spTree>
     <p:extLst>
       <p:ext uri="{BB962C8B-B14F-4D97-AF65-F5344CB8AC3E}">

</xml_diff>